<commit_message>
docs: update EventHub Framework presentation
Co-Authored-By: Claude Sonnet 4.6 <noreply@anthropic.com>
</commit_message>
<xml_diff>
--- a/EventHub_Framework.pptx
+++ b/EventHub_Framework.pptx
@@ -9156,7 +9156,7 @@
                   <a:srgbClr val="E01E5A"/>
                 </a:solidFill>
               </a:rPr>
-              <a:t>Slack + GitHub App</a:t>
+              <a:t>GitHub Actions</a:t>
             </a:r>
             <a:endParaRPr lang="en-US" sz="1150" dirty="0"/>
           </a:p>
@@ -9355,7 +9355,7 @@
                   <a:srgbClr val="FF4757"/>
                 </a:solidFill>
               </a:rPr>
-              <a:t>Production-grade  ·  AI-assisted  ·  Self-healing  ·  CI-verified  ·  Zero cost</a:t>
+              <a:t>Production-grade  ·  AI-assisted  ·  Self-healing  ·  CI-verified  · </a:t>
             </a:r>
             <a:endParaRPr lang="en-US" sz="1300" dirty="0"/>
           </a:p>
@@ -19981,9 +19981,9 @@
                   <a:srgbClr val="64748B"/>
                 </a:solidFill>
               </a:rPr>
-              <a:t>"Add test for TC-056"</a:t>
-            </a:r>
-            <a:endParaRPr lang="en-US" sz="850" dirty="0"/>
+              <a:t>Copy prompt from prompts.md, replace TC-XXX with TC-056</a:t>
+            </a:r>
+            <a:endParaRPr lang="en-US" altLang="en-US" sz="850" dirty="0"/>
           </a:p>
         </p:txBody>
       </p:sp>
@@ -20510,6 +20510,12 @@
             </a:outerShdw>
           </a:effectLst>
         </p:spPr>
+        <p:txBody>
+          <a:bodyPr/>
+          <a:p>
+            <a:endParaRPr lang="en-US"/>
+          </a:p>
+        </p:txBody>
       </p:sp>
       <p:sp>
         <p:nvSpPr>
@@ -20744,7 +20750,10 @@
           <a:bodyPr wrap="square" lIns="0" tIns="0" rIns="0" bIns="0" rtlCol="0" anchor="ctr"/>
           <a:lstStyle/>
           <a:p>
-            <a:pPr marL="0" indent="0">
+            <a:pPr marL="0" algn="l">
+              <a:buClrTx/>
+              <a:buSzTx/>
+              <a:buFontTx/>
               <a:buNone/>
             </a:pPr>
             <a:r>
@@ -20753,9 +20762,13 @@
                   <a:srgbClr val="64748B"/>
                 </a:solidFill>
               </a:rPr>
-              <a:t>"Add tests for EventBooking module"</a:t>
-            </a:r>
-            <a:endParaRPr lang="en-US" sz="850" dirty="0"/>
+              <a:t>Copy prompt from prompts.md, specify module name</a:t>
+            </a:r>
+            <a:endParaRPr lang="en-US" sz="850" dirty="0">
+              <a:solidFill>
+                <a:srgbClr val="64748B"/>
+              </a:solidFill>
+            </a:endParaRPr>
           </a:p>
         </p:txBody>
       </p:sp>

</xml_diff>